<commit_message>
feat: update Lean UX problem statement and assumptions; add new image and remove obsolete files
</commit_message>
<xml_diff>
--- a/assets/lean-ux-canvas/LeanUX_canvas_v5.pptx
+++ b/assets/lean-ux-canvas/LeanUX_canvas_v5.pptx
@@ -4113,7 +4113,7 @@
         </p:nvSpPr>
         <p:spPr bwMode="auto">
           <a:xfrm>
-            <a:off x="457200" y="1054100"/>
+            <a:off x="457200" y="1059815"/>
             <a:ext cx="14630400" cy="8686800"/>
           </a:xfrm>
           <a:prstGeom prst="rect">
@@ -4158,7 +4158,7 @@
         <p:spPr bwMode="auto">
           <a:xfrm>
             <a:off x="152400" y="228600"/>
-            <a:ext cx="4800600" cy="646113"/>
+            <a:ext cx="4800600" cy="645160"/>
           </a:xfrm>
           <a:prstGeom prst="rect">
             <a:avLst/>
@@ -4287,7 +4287,7 @@
                 <a:latin typeface="Helvetica" charset="0"/>
                 <a:cs typeface="Helvetica" charset="0"/>
               </a:rPr>
-              <a:t>Lean UX Canvas (v2)</a:t>
+              <a:t>Lean UX Canvas</a:t>
             </a:r>
             <a:endParaRPr lang="en-US" sz="3600" dirty="0">
               <a:latin typeface="Helvetica" charset="0"/>
@@ -4304,8 +4304,8 @@
         </p:nvSpPr>
         <p:spPr bwMode="auto">
           <a:xfrm>
-            <a:off x="457200" y="3802856"/>
-            <a:ext cx="5410200" cy="3207544"/>
+            <a:off x="457200" y="3008630"/>
+            <a:ext cx="5410200" cy="2451100"/>
           </a:xfrm>
           <a:prstGeom prst="rect">
             <a:avLst/>
@@ -4339,7 +4339,7 @@
               </a:rPr>
               <a:t>Users</a:t>
             </a:r>
-            <a:endParaRPr lang="en-US" sz="2000" b="1" dirty="0">
+            <a:endParaRPr lang="en-US" sz="1000" dirty="0">
               <a:latin typeface="Helvetica Neue"/>
               <a:cs typeface="Helvetica Neue"/>
             </a:endParaRPr>
@@ -4353,7 +4353,7 @@
                 <a:latin typeface="Helvetica Neue"/>
                 <a:cs typeface="Helvetica Neue"/>
               </a:rPr>
-              <a:t>What types (i.e., personas) of users and customers should you focus on first?</a:t>
+              <a:t>Debemos enfocarnos primero en dos tipos principales de usuarios y clientes:</a:t>
             </a:r>
             <a:endParaRPr lang="en-US" sz="1000" dirty="0">
               <a:latin typeface="Helvetica Neue"/>
@@ -4361,31 +4361,55 @@
             </a:endParaRPr>
           </a:p>
           <a:p>
-            <a:pPr>
-              <a:defRPr/>
-            </a:pPr>
-            <a:r>
-              <a:rPr lang="en-US" sz="1000" i="1" dirty="0">
+            <a:pPr marL="171450" indent="-171450">
+              <a:buFont typeface="Arial" panose="020B0604020202020204" pitchFamily="34" charset="0"/>
+              <a:buChar char="•"/>
+              <a:defRPr/>
+            </a:pPr>
+            <a:r>
+              <a:rPr lang="en-US" sz="1000" dirty="0">
                 <a:latin typeface="Helvetica Neue"/>
                 <a:cs typeface="Helvetica Neue"/>
               </a:rPr>
-              <a:t>(Hint: Who buys your product or service? Who uses it? Who configures it? </a:t>
-            </a:r>
-            <a:r>
-              <a:rPr lang="en-US" sz="1000" i="1" dirty="0" err="1">
+              <a:t>Administradores de establecimientos públicos y privados, porque son quienes compran, implementan y supervisan el uso de la solución dentro de sus espacios. Este grupo es clave ya que toma decisiones sobre inversión, configura el monitoreo y utiliza la Web App para revisar reportes, recibir alertas y demostrar que su establecimiento es seguro.</a:t>
+            </a:r>
+            <a:endParaRPr lang="en-US" sz="1000" dirty="0">
+              <a:latin typeface="Helvetica Neue"/>
+              <a:cs typeface="Helvetica Neue"/>
+            </a:endParaRPr>
+          </a:p>
+          <a:p>
+            <a:pPr marL="171450" indent="-171450">
+              <a:buFont typeface="Arial" panose="020B0604020202020204" pitchFamily="34" charset="0"/>
+              <a:buChar char="•"/>
+              <a:defRPr/>
+            </a:pPr>
+            <a:r>
+              <a:rPr lang="en-US" sz="1000" dirty="0">
                 <a:latin typeface="Helvetica Neue"/>
                 <a:cs typeface="Helvetica Neue"/>
               </a:rPr>
-              <a:t>Etc</a:t>
-            </a:r>
-            <a:r>
-              <a:rPr lang="en-US" sz="1000" i="1" dirty="0">
+              <a:t>Personas preocupadas por la calidad del aire en el hogar, porque son los usuarios finales que buscan monitorear su vivienda para proteger la salud de su familia. Este grupo usa directamente la aplicación móvil, interpreta los indicadores visuales y actúa ante alertas para mejorar la ventilación y reducir riesgos.</a:t>
+            </a:r>
+            <a:endParaRPr lang="en-US" sz="1000" dirty="0">
+              <a:latin typeface="Helvetica Neue"/>
+              <a:cs typeface="Helvetica Neue"/>
+            </a:endParaRPr>
+          </a:p>
+          <a:p>
+            <a:pPr marL="0" indent="0">
+              <a:buFont typeface="Arial" panose="020B0604020202020204" pitchFamily="34" charset="0"/>
+              <a:buNone/>
+              <a:defRPr/>
+            </a:pPr>
+            <a:r>
+              <a:rPr lang="en-US" sz="1000" dirty="0">
                 <a:latin typeface="Helvetica Neue"/>
                 <a:cs typeface="Helvetica Neue"/>
               </a:rPr>
-              <a:t>)</a:t>
-            </a:r>
-            <a:endParaRPr lang="en-US" sz="1000" i="1" dirty="0">
+              <a:t>En una primera etapa, el foco principal debería estar en los administradores de establecimientos, ya que representan al cliente que compra la solución y generan validación inicial del valor de negocio.</a:t>
+            </a:r>
+            <a:endParaRPr lang="en-US" sz="1000" dirty="0">
               <a:latin typeface="Helvetica Neue"/>
               <a:cs typeface="Helvetica Neue"/>
             </a:endParaRPr>
@@ -4400,8 +4424,8 @@
         </p:nvSpPr>
         <p:spPr bwMode="auto">
           <a:xfrm>
-            <a:off x="5867400" y="1052512"/>
-            <a:ext cx="3809998" cy="5957888"/>
+            <a:off x="5867400" y="1052195"/>
+            <a:ext cx="3810000" cy="3297555"/>
           </a:xfrm>
           <a:prstGeom prst="rect">
             <a:avLst/>
@@ -4441,7 +4465,8 @@
             </a:endParaRPr>
           </a:p>
           <a:p>
-            <a:pPr>
+            <a:pPr marL="228600" indent="-228600">
+              <a:buAutoNum type="arabicPeriod"/>
               <a:defRPr/>
             </a:pPr>
             <a:r>
@@ -4449,13 +4474,115 @@
                 <a:latin typeface="Helvetica Neue"/>
                 <a:cs typeface="Helvetica Neue"/>
               </a:rPr>
-              <a:t>What can we make that will solve our business problem and meet the needs of our customers at the same time? List product, feature, or enhancement ideas here. </a:t>
+              <a:t>Un sensor inteligente que mida en tiempo real los niveles de PM2.5 y CO2 en espacios cerrados.</a:t>
             </a:r>
             <a:endParaRPr lang="en-US" sz="1000" dirty="0">
               <a:latin typeface="Helvetica Neue"/>
               <a:cs typeface="Helvetica Neue"/>
             </a:endParaRPr>
           </a:p>
+          <a:p>
+            <a:pPr marL="228600" indent="-228600">
+              <a:buAutoNum type="arabicPeriod"/>
+              <a:defRPr/>
+            </a:pPr>
+            <a:r>
+              <a:rPr lang="en-US" sz="1000" dirty="0">
+                <a:latin typeface="Helvetica Neue"/>
+                <a:cs typeface="Helvetica Neue"/>
+              </a:rPr>
+              <a:t>Una aplicación web para administradores de establecimientos que permita visualizar el estado de la calidad del aire, revisar reportes históricos y monitorear varios espacios.</a:t>
+            </a:r>
+            <a:endParaRPr lang="en-US" sz="1000" dirty="0">
+              <a:latin typeface="Helvetica Neue"/>
+              <a:cs typeface="Helvetica Neue"/>
+            </a:endParaRPr>
+          </a:p>
+          <a:p>
+            <a:pPr marL="228600" indent="-228600">
+              <a:buAutoNum type="arabicPeriod"/>
+              <a:defRPr/>
+            </a:pPr>
+            <a:r>
+              <a:rPr lang="en-US" sz="1000" dirty="0">
+                <a:latin typeface="Helvetica Neue"/>
+                <a:cs typeface="Helvetica Neue"/>
+              </a:rPr>
+              <a:t>Una aplicación móvil para usuarios del hogar y administradores que muestre indicadores visuales simples sobre la calidad del aire.</a:t>
+            </a:r>
+            <a:endParaRPr lang="en-US" sz="1000" dirty="0">
+              <a:latin typeface="Helvetica Neue"/>
+              <a:cs typeface="Helvetica Neue"/>
+            </a:endParaRPr>
+          </a:p>
+          <a:p>
+            <a:pPr marL="228600" indent="-228600">
+              <a:buAutoNum type="arabicPeriod"/>
+              <a:defRPr/>
+            </a:pPr>
+            <a:r>
+              <a:rPr lang="en-US" sz="1000" dirty="0">
+                <a:latin typeface="Helvetica Neue"/>
+                <a:cs typeface="Helvetica Neue"/>
+              </a:rPr>
+              <a:t>Alertas en tiempo real cuando los niveles de CO2 o PM2.5 superen los límites recomendados.</a:t>
+            </a:r>
+            <a:endParaRPr lang="en-US" sz="1000" dirty="0">
+              <a:latin typeface="Helvetica Neue"/>
+              <a:cs typeface="Helvetica Neue"/>
+            </a:endParaRPr>
+          </a:p>
+          <a:p>
+            <a:pPr marL="228600" indent="-228600">
+              <a:buAutoNum type="arabicPeriod"/>
+              <a:defRPr/>
+            </a:pPr>
+            <a:r>
+              <a:rPr lang="en-US" sz="1000" dirty="0">
+                <a:latin typeface="Helvetica Neue"/>
+                <a:cs typeface="Helvetica Neue"/>
+              </a:rPr>
+              <a:t>Reportes históricos que ayuden a demostrar condiciones adecuadas de salubridad y respalden decisiones operativas.</a:t>
+            </a:r>
+            <a:endParaRPr lang="en-US" sz="1000" dirty="0">
+              <a:latin typeface="Helvetica Neue"/>
+              <a:cs typeface="Helvetica Neue"/>
+            </a:endParaRPr>
+          </a:p>
+          <a:p>
+            <a:pPr marL="228600" indent="-228600">
+              <a:buAutoNum type="arabicPeriod"/>
+              <a:defRPr/>
+            </a:pPr>
+            <a:r>
+              <a:rPr lang="en-US" sz="1000" dirty="0">
+                <a:latin typeface="Helvetica Neue"/>
+                <a:cs typeface="Helvetica Neue"/>
+              </a:rPr>
+              <a:t>Un sistema de visualización basado en colores y niveles para que cualquier usuario pueda entender rápidamente el estado del aire</a:t>
+            </a:r>
+            <a:endParaRPr lang="en-US" sz="1000" dirty="0">
+              <a:latin typeface="Helvetica Neue"/>
+              <a:cs typeface="Helvetica Neue"/>
+            </a:endParaRPr>
+          </a:p>
+          <a:p>
+            <a:pPr marL="228600" indent="-228600">
+              <a:buAutoNum type="arabicPeriod"/>
+              <a:defRPr/>
+            </a:pPr>
+            <a:r>
+              <a:rPr lang="en-US" sz="1000" dirty="0">
+                <a:latin typeface="Helvetica Neue"/>
+                <a:cs typeface="Helvetica Neue"/>
+              </a:rPr>
+              <a:t>Un modelo de monitoreo continuo que combine hardware y software en una solución accesible y fácil de usar. </a:t>
+            </a:r>
+            <a:endParaRPr lang="en-US" sz="1000" dirty="0">
+              <a:latin typeface="Helvetica Neue"/>
+              <a:cs typeface="Helvetica Neue"/>
+            </a:endParaRPr>
+          </a:p>
         </p:txBody>
       </p:sp>
       <p:sp>
@@ -4466,8 +4593,8 @@
         </p:nvSpPr>
         <p:spPr bwMode="auto">
           <a:xfrm>
-            <a:off x="9677400" y="3810000"/>
-            <a:ext cx="5419724" cy="3200400"/>
+            <a:off x="9677400" y="3825240"/>
+            <a:ext cx="5419725" cy="5916295"/>
           </a:xfrm>
           <a:prstGeom prst="rect">
             <a:avLst/>
@@ -4515,7 +4642,7 @@
                 <a:latin typeface="Helvetica Neue"/>
                 <a:cs typeface="Helvetica Neue"/>
               </a:rPr>
-              <a:t>Why would your users seek out your product or service? What benefit would they gain from using it? What behavior change can we observe that tells us they've achieved their goal?</a:t>
+              <a:t>Los usuarios buscarían nuestro producto porque les permite conocer en tiempo real la calidad del aire interior en los espacios que administran o frecuentan, algo que hoy no pueden visualizar fácilmente. El principal beneficio que obtienen es mayor seguridad, confianza y capacidad de tomar decisiones oportunas para proteger la salud, mejorar la ventilación y ofrecer un ambiente más saludable.</a:t>
             </a:r>
             <a:endParaRPr lang="en-US" sz="1000" dirty="0">
               <a:latin typeface="Helvetica Neue"/>
@@ -4526,14 +4653,23 @@
             <a:pPr>
               <a:defRPr/>
             </a:pPr>
-            <a:r>
-              <a:rPr lang="en-US" sz="1000" i="1" dirty="0">
+            <a:endParaRPr lang="en-US" sz="1000" dirty="0">
+              <a:latin typeface="Helvetica Neue"/>
+              <a:cs typeface="Helvetica Neue"/>
+            </a:endParaRPr>
+          </a:p>
+          <a:p>
+            <a:pPr>
+              <a:defRPr/>
+            </a:pPr>
+            <a:r>
+              <a:rPr lang="en-US" sz="1000" dirty="0">
                 <a:latin typeface="Helvetica Neue"/>
                 <a:cs typeface="Helvetica Neue"/>
               </a:rPr>
-              <a:t>(Hint: Save money, get a promotion, spend more time with family)</a:t>
-            </a:r>
-            <a:endParaRPr lang="en-US" sz="1000" i="1" dirty="0">
+              <a:t>Sabremos que lograron su objetivo cuando observemos cambios en su comportamiento, como revisar con frecuencia los indicadores de calidad del aire, responder a las alertas, aplicar recomendaciones como ventilar el espacio o reducir el aforo, y usar los reportes para mantener condiciones más seguras de manera continua.</a:t>
+            </a:r>
+            <a:endParaRPr lang="en-US" sz="1000" dirty="0">
               <a:latin typeface="Helvetica Neue"/>
               <a:cs typeface="Helvetica Neue"/>
             </a:endParaRPr>
@@ -4548,8 +4684,8 @@
         </p:nvSpPr>
         <p:spPr bwMode="auto">
           <a:xfrm>
-            <a:off x="486064" y="7017544"/>
-            <a:ext cx="5381333" cy="2723356"/>
+            <a:off x="485775" y="5459730"/>
+            <a:ext cx="5381625" cy="4281170"/>
           </a:xfrm>
           <a:prstGeom prst="rect">
             <a:avLst/>
@@ -4589,7 +4725,8 @@
             </a:endParaRPr>
           </a:p>
           <a:p>
-            <a:pPr>
+            <a:pPr marL="228600" indent="-228600">
+              <a:buAutoNum type="arabicPeriod"/>
               <a:defRPr/>
             </a:pPr>
             <a:r>
@@ -4597,38 +4734,77 @@
                 <a:latin typeface="Helvetica Neue"/>
                 <a:cs typeface="Helvetica Neue"/>
               </a:rPr>
-              <a:t>Combine the assumptions from 2, 3, 4 &amp; 5 into the following hypothesis statement: </a:t>
-            </a:r>
-            <a:br>
+              <a:t>Creemos que los administradores de espacios comerciales tomarán mejores decisiones para proteger la salud de sus clientes y mejorar la confianza en su negocio. Sabremos que esto es cierto cuando al menos el 50% de los administradores consulten en tiempo real los datos de PM2.5 y CO2 de sus espacios al menos una vez por día.</a:t>
+            </a:r>
+            <a:endParaRPr lang="en-US" sz="1000" dirty="0">
+              <a:latin typeface="Helvetica Neue"/>
+              <a:cs typeface="Helvetica Neue"/>
+            </a:endParaRPr>
+          </a:p>
+          <a:p>
+            <a:pPr marL="228600" indent="-228600">
+              <a:buAutoNum type="arabicPeriod"/>
+              <a:defRPr/>
+            </a:pPr>
+            <a:r>
               <a:rPr lang="en-US" sz="1000" dirty="0">
                 <a:latin typeface="Helvetica Neue"/>
                 <a:cs typeface="Helvetica Neue"/>
               </a:rPr>
-            </a:br>
-            <a:r>
-              <a:rPr lang="en-US" sz="1000" i="1" dirty="0">
+              <a:t>Creemos que los usuarios comprenderán más fácilmente el estado de la calidad del aire interior. Sabremos que esto es cierto cuando al menos el 70% de los usuarios interpreten correctamente los niveles de riesgo usando la interfaz visual de colores y niveles sin necesidad de explicación adicional.</a:t>
+            </a:r>
+            <a:endParaRPr lang="en-US" sz="1000" dirty="0">
+              <a:latin typeface="Helvetica Neue"/>
+              <a:cs typeface="Helvetica Neue"/>
+            </a:endParaRPr>
+          </a:p>
+          <a:p>
+            <a:pPr marL="228600" indent="-228600">
+              <a:buAutoNum type="arabicPeriod"/>
+              <a:defRPr/>
+            </a:pPr>
+            <a:r>
+              <a:rPr lang="en-US" sz="1000" dirty="0">
                 <a:latin typeface="Helvetica Neue"/>
                 <a:cs typeface="Helvetica Neue"/>
               </a:rPr>
-              <a:t>“We believe that [business outcome] will be achieved if [user] attains [benefit] with [feature].”</a:t>
-            </a:r>
-            <a:endParaRPr lang="en-US" sz="1000" i="1" dirty="0">
+              <a:t>Creemos que los administradores y usuarios reaccionarán oportunamente ante episodios de mala calidad del aire. Sabremos que esto es cierto cuando al menos el 40% de las alertas generadas produzcan una acción correctiva, como ventilar el espacio o reducir el aforo.</a:t>
+            </a:r>
+            <a:endParaRPr lang="en-US" sz="1000" dirty="0">
               <a:latin typeface="Helvetica Neue"/>
               <a:cs typeface="Helvetica Neue"/>
             </a:endParaRPr>
           </a:p>
           <a:p>
-            <a:pPr>
-              <a:defRPr/>
-            </a:pPr>
-            <a:r>
-              <a:rPr lang="en-US" sz="1000" i="1" dirty="0">
+            <a:pPr marL="228600" indent="-228600">
+              <a:buAutoNum type="arabicPeriod"/>
+              <a:defRPr/>
+            </a:pPr>
+            <a:r>
+              <a:rPr lang="en-US" sz="1000" dirty="0">
                 <a:latin typeface="Helvetica Neue"/>
                 <a:cs typeface="Helvetica Neue"/>
               </a:rPr>
-              <a:t>(Hint: Each hypothesis should focus on one feature only.)</a:t>
-            </a:r>
-            <a:endParaRPr lang="en-US" sz="1000" i="1" dirty="0">
+              <a:t>Creemos que los administradores percibirán mayor valor en la plataforma al contar con evidencia histórica sobre la calidad del aire de sus locales. Sabremos que esto es cierto cuando al menos el 50% de los administradores revisen o descarguen reportes históricos al menos una vez por semana.</a:t>
+            </a:r>
+            <a:endParaRPr lang="en-US" sz="1000" dirty="0">
+              <a:latin typeface="Helvetica Neue"/>
+              <a:cs typeface="Helvetica Neue"/>
+            </a:endParaRPr>
+          </a:p>
+          <a:p>
+            <a:pPr marL="228600" indent="-228600">
+              <a:buAutoNum type="arabicPeriod"/>
+              <a:defRPr/>
+            </a:pPr>
+            <a:r>
+              <a:rPr lang="en-US" sz="1000" dirty="0">
+                <a:latin typeface="Helvetica Neue"/>
+                <a:cs typeface="Helvetica Neue"/>
+              </a:rPr>
+              <a:t>Creemos que los usuarios mejorarán las condiciones de su entorno siguiendo la orientación de la plataforma. Sabremos que esto es cierto cuando al menos el 40% de los usuarios apliquen las recomendaciones automáticas y registren una mejora en los niveles de calidad del aire durante el periodo de uso.</a:t>
+            </a:r>
+            <a:endParaRPr lang="en-US" sz="1000" dirty="0">
               <a:latin typeface="Helvetica Neue"/>
               <a:cs typeface="Helvetica Neue"/>
             </a:endParaRPr>
@@ -4643,8 +4819,8 @@
         </p:nvSpPr>
         <p:spPr bwMode="auto">
           <a:xfrm>
-            <a:off x="9677399" y="7010400"/>
-            <a:ext cx="5419726" cy="2730500"/>
+            <a:off x="9677400" y="6205855"/>
+            <a:ext cx="5419725" cy="3535045"/>
           </a:xfrm>
           <a:prstGeom prst="rect">
             <a:avLst/>
@@ -4692,14 +4868,50 @@
                 <a:latin typeface="Helvetica Neue"/>
                 <a:cs typeface="Helvetica Neue"/>
               </a:rPr>
-              <a:t>Design experiments to learn as fast as you can whether your riskiest assumption is true or false. </a:t>
-            </a:r>
-            <a:endParaRPr lang="en-US" sz="1000" b="1" dirty="0">
-              <a:solidFill>
-                <a:schemeClr val="bg1">
-                  <a:lumMod val="50000"/>
-                </a:schemeClr>
-              </a:solidFill>
+              <a:t>La menor cantidad de trabajo que necesitamos hacer para aprender lo siguiente más importante es realizar entrevistas y pruebas rápidas con administradores de espacios comerciales usando una propuesta de valor simple y un prototipo básico de la solución. De esta manera podremos validar si realmente consideran importante monitorear la calidad del aire interior y si perciben valor en usar una herramienta como Clair.</a:t>
+            </a:r>
+            <a:endParaRPr lang="en-US" sz="1000" dirty="0">
+              <a:latin typeface="Helvetica Neue"/>
+              <a:cs typeface="Helvetica Neue"/>
+            </a:endParaRPr>
+          </a:p>
+          <a:p>
+            <a:pPr>
+              <a:defRPr/>
+            </a:pPr>
+            <a:endParaRPr lang="en-US" sz="1000" dirty="0">
+              <a:latin typeface="Helvetica Neue"/>
+              <a:cs typeface="Helvetica Neue"/>
+            </a:endParaRPr>
+          </a:p>
+          <a:p>
+            <a:pPr>
+              <a:defRPr/>
+            </a:pPr>
+            <a:r>
+              <a:rPr lang="en-US" sz="1000" dirty="0">
+                <a:latin typeface="Helvetica Neue"/>
+                <a:cs typeface="Helvetica Neue"/>
+              </a:rPr>
+              <a:t>Para aprender lo más rápido posible si nuestro supuesto más riesgoso es verdadero o falso, podemos diseñar experimentos como mostrar una landing page o mockup del producto, presentar ejemplos de alertas, visualizaciones y</a:t>
+            </a:r>
+            <a:endParaRPr lang="en-US" sz="1000" dirty="0">
+              <a:latin typeface="Helvetica Neue"/>
+              <a:cs typeface="Helvetica Neue"/>
+            </a:endParaRPr>
+          </a:p>
+          <a:p>
+            <a:pPr>
+              <a:defRPr/>
+            </a:pPr>
+            <a:r>
+              <a:rPr lang="en-US" sz="1000" dirty="0">
+                <a:latin typeface="Helvetica Neue"/>
+                <a:cs typeface="Helvetica Neue"/>
+              </a:rPr>
+              <a:t> reportes, y luego medir si los administradores entienden el problema, muestran interés real, solicitan más información o estarían dispuestos a probar la solución en su local. Si no muestran interés ni perciben valor, sabremos tempranamente que debemos replantear la propuesta antes de invertir en mayor desarrollo.</a:t>
+            </a:r>
+            <a:endParaRPr lang="en-US" sz="1000" dirty="0">
               <a:latin typeface="Helvetica Neue"/>
               <a:cs typeface="Helvetica Neue"/>
             </a:endParaRPr>
@@ -4714,8 +4926,8 @@
         </p:nvSpPr>
         <p:spPr bwMode="auto">
           <a:xfrm>
-            <a:off x="457201" y="1059656"/>
-            <a:ext cx="5410200" cy="2743200"/>
+            <a:off x="457200" y="1059815"/>
+            <a:ext cx="5410200" cy="1948180"/>
           </a:xfrm>
           <a:prstGeom prst="rect">
             <a:avLst/>
@@ -4763,36 +4975,9 @@
                 <a:latin typeface="Helvetica Neue"/>
                 <a:cs typeface="Helvetica Neue"/>
               </a:rPr>
-              <a:t>What problem does the business have that you are trying to solve? </a:t>
-            </a:r>
-            <a:br>
-              <a:rPr lang="en-US" sz="1000" dirty="0">
-                <a:latin typeface="Helvetica Neue"/>
-                <a:cs typeface="Helvetica Neue"/>
-              </a:rPr>
-            </a:br>
-            <a:r>
-              <a:rPr lang="en-US" sz="1000" i="1" dirty="0">
-                <a:latin typeface="Helvetica Neue"/>
-                <a:cs typeface="Helvetica Neue"/>
-              </a:rPr>
-              <a:t>(Hint: Consider your current offerings and how </a:t>
-            </a:r>
-            <a:r>
-              <a:rPr lang="en-US" sz="1000" i="1">
-                <a:latin typeface="Helvetica Neue"/>
-                <a:cs typeface="Helvetica Neue"/>
-              </a:rPr>
-              <a:t>they deliver </a:t>
-            </a:r>
-            <a:r>
-              <a:rPr lang="en-US" sz="1000" i="1" dirty="0">
-                <a:latin typeface="Helvetica Neue"/>
-                <a:cs typeface="Helvetica Neue"/>
-              </a:rPr>
-              <a:t>value, changes in the market, delivery channels, competitive threats and customer behavior.)</a:t>
-            </a:r>
-            <a:endParaRPr lang="en-US" sz="1000" i="1" dirty="0">
+              <a:t>El problema de negocio es que los espacios comerciales cerrados de Lima Metropolitana no cuentan con una solución accesible para monitorear y gestionar la calidad del aire interior en tiempo real. Esto impide a los administradores identificar niveles críticos de PM2.5 y CO2, tomar decisiones oportunas para mejorar la ventilación y demostrar a sus clientes que el local es seguro y saludable. Como resultado, los negocios operan con un riesgo invisible que afecta la experiencia del usuario, la percepción de confianza y su capacidad de diferenciarse competitivamente en el mercado.</a:t>
+            </a:r>
+            <a:endParaRPr lang="en-US" sz="1000" dirty="0">
               <a:latin typeface="Helvetica Neue"/>
               <a:cs typeface="Helvetica Neue"/>
             </a:endParaRPr>
@@ -4808,7 +4993,7 @@
         <p:spPr bwMode="auto">
           <a:xfrm>
             <a:off x="9677400" y="1066800"/>
-            <a:ext cx="5419725" cy="2743200"/>
+            <a:ext cx="5419725" cy="2780030"/>
           </a:xfrm>
           <a:prstGeom prst="rect">
             <a:avLst/>
@@ -4840,20 +5025,23 @@
                 <a:latin typeface="Helvetica Neue"/>
                 <a:cs typeface="Helvetica Neue"/>
               </a:rPr>
-              <a:t>Business Outcomes </a:t>
-            </a:r>
-            <a:br>
-              <a:rPr lang="en-US" sz="2000" b="1" dirty="0">
-                <a:latin typeface="Helvetica Neue"/>
-                <a:cs typeface="Helvetica Neue"/>
-              </a:rPr>
-            </a:br>
+              <a:t>Business Outcomes</a:t>
+            </a:r>
+            <a:endParaRPr lang="en-US" sz="2000" b="1" dirty="0">
+              <a:latin typeface="Helvetica Neue"/>
+              <a:cs typeface="Helvetica Neue"/>
+            </a:endParaRPr>
+          </a:p>
+          <a:p>
+            <a:pPr>
+              <a:defRPr/>
+            </a:pPr>
             <a:r>
               <a:rPr lang="en-US" sz="1000" dirty="0">
                 <a:latin typeface="Helvetica Neue"/>
                 <a:cs typeface="Helvetica Neue"/>
               </a:rPr>
-              <a:t>How will you know you solved the business problem? What will you measure? </a:t>
+              <a:t>Sabremos que resolvimos el problema de negocio cuando los administradores de espacios comerciales usen activamente la solución para monitorear la calidad del aire y tomen decisiones basadas en la información proporcionada. Esto se reflejará en una adopción sostenida de la plataforma, en el uso frecuente de los datos, alertas y reportes, y en una mayor percepción de confianza y seguridad por parte de los clientes.</a:t>
             </a:r>
             <a:endParaRPr lang="en-US" sz="1000" dirty="0">
               <a:latin typeface="Helvetica Neue"/>
@@ -4864,26 +5052,136 @@
             <a:pPr>
               <a:defRPr/>
             </a:pPr>
+            <a:endParaRPr lang="en-US" sz="1000" dirty="0">
+              <a:latin typeface="Helvetica Neue"/>
+              <a:cs typeface="Helvetica Neue"/>
+            </a:endParaRPr>
+          </a:p>
+          <a:p>
+            <a:pPr>
+              <a:defRPr/>
+            </a:pPr>
+            <a:r>
+              <a:rPr lang="en-US" sz="1000" dirty="0">
+                <a:latin typeface="Helvetica Neue"/>
+                <a:cs typeface="Helvetica Neue"/>
+              </a:rPr>
+              <a:t>Mediremos esto a través de los siguientes indicadores:</a:t>
+            </a:r>
+            <a:endParaRPr lang="en-US" sz="1000" dirty="0">
+              <a:latin typeface="Helvetica Neue"/>
+              <a:cs typeface="Helvetica Neue"/>
+            </a:endParaRPr>
+          </a:p>
+          <a:p>
+            <a:pPr marL="171450" indent="-171450">
+              <a:buFont typeface="Arial" panose="020B0604020202020204" pitchFamily="34" charset="0"/>
+              <a:buChar char="•"/>
+              <a:defRPr/>
+            </a:pPr>
+            <a:r>
+              <a:rPr lang="en-US" sz="1000" dirty="0">
+                <a:latin typeface="Helvetica Neue"/>
+                <a:cs typeface="Helvetica Neue"/>
+              </a:rPr>
+              <a:t>Cantidad de negocios que implementan la solución.</a:t>
+            </a:r>
+            <a:endParaRPr lang="en-US" sz="1000" dirty="0">
+              <a:latin typeface="Helvetica Neue"/>
+              <a:cs typeface="Helvetica Neue"/>
+            </a:endParaRPr>
+          </a:p>
+          <a:p>
+            <a:pPr marL="171450" indent="-171450">
+              <a:buFont typeface="Arial" panose="020B0604020202020204" pitchFamily="34" charset="0"/>
+              <a:buChar char="•"/>
+              <a:defRPr/>
+            </a:pPr>
+            <a:r>
+              <a:rPr lang="en-US" sz="1000" dirty="0">
+                <a:latin typeface="Helvetica Neue"/>
+                <a:cs typeface="Helvetica Neue"/>
+              </a:rPr>
+              <a:t>Frecuencia de uso de la plataforma por parte de los administradores.</a:t>
+            </a:r>
+            <a:endParaRPr lang="en-US" sz="1000" dirty="0">
+              <a:latin typeface="Helvetica Neue"/>
+              <a:cs typeface="Helvetica Neue"/>
+            </a:endParaRPr>
+          </a:p>
+          <a:p>
+            <a:pPr marL="171450" indent="-171450">
+              <a:buFont typeface="Arial" panose="020B0604020202020204" pitchFamily="34" charset="0"/>
+              <a:buChar char="•"/>
+              <a:defRPr/>
+            </a:pPr>
+            <a:r>
+              <a:rPr lang="en-US" sz="1000" dirty="0">
+                <a:latin typeface="Helvetica Neue"/>
+                <a:cs typeface="Helvetica Neue"/>
+              </a:rPr>
+              <a:t>Porcentaje de usuarios que revisan alertas y reportes de calidad del aire.</a:t>
+            </a:r>
+            <a:endParaRPr lang="en-US" sz="1000" dirty="0">
+              <a:latin typeface="Helvetica Neue"/>
+              <a:cs typeface="Helvetica Neue"/>
+            </a:endParaRPr>
+          </a:p>
+          <a:p>
+            <a:pPr marL="171450" indent="-171450">
+              <a:buFont typeface="Arial" panose="020B0604020202020204" pitchFamily="34" charset="0"/>
+              <a:buChar char="•"/>
+              <a:defRPr/>
+            </a:pPr>
+            <a:r>
+              <a:rPr lang="en-US" sz="1000" dirty="0">
+                <a:latin typeface="Helvetica Neue"/>
+                <a:cs typeface="Helvetica Neue"/>
+              </a:rPr>
+              <a:t>Tasa de retención de negocios suscritos al servicio.</a:t>
+            </a:r>
+            <a:endParaRPr lang="en-US" sz="1000" dirty="0">
+              <a:latin typeface="Helvetica Neue"/>
+              <a:cs typeface="Helvetica Neue"/>
+            </a:endParaRPr>
+          </a:p>
+          <a:p>
+            <a:pPr marL="171450" indent="-171450">
+              <a:buFont typeface="Arial" panose="020B0604020202020204" pitchFamily="34" charset="0"/>
+              <a:buChar char="•"/>
+              <a:defRPr/>
+            </a:pPr>
+            <a:r>
+              <a:rPr lang="en-US" sz="1000" dirty="0">
+                <a:latin typeface="Helvetica Neue"/>
+                <a:cs typeface="Helvetica Neue"/>
+              </a:rPr>
+              <a:t>Cantidad de acciones correctivas realizadas a partir de alertas o recomendaciones.</a:t>
+            </a:r>
+            <a:endParaRPr lang="en-US" sz="1000" dirty="0">
+              <a:latin typeface="Helvetica Neue"/>
+              <a:cs typeface="Helvetica Neue"/>
+            </a:endParaRPr>
+          </a:p>
+          <a:p>
+            <a:pPr marL="171450" indent="-171450">
+              <a:buFont typeface="Arial" panose="020B0604020202020204" pitchFamily="34" charset="0"/>
+              <a:buChar char="•"/>
+              <a:defRPr/>
+            </a:pPr>
+            <a:r>
+              <a:rPr lang="en-US" sz="1000" dirty="0">
+                <a:latin typeface="Helvetica Neue"/>
+                <a:cs typeface="Helvetica Neue"/>
+              </a:rPr>
+              <a:t>Nivel de satisfacción y confianza percibida por los clientes en los espacios monitoreados.</a:t>
+            </a:r>
             <a:r>
               <a:rPr lang="en-US" sz="1000" i="1" dirty="0">
                 <a:latin typeface="Helvetica Neue"/>
                 <a:cs typeface="Helvetica Neue"/>
               </a:rPr>
-              <a:t>(Hint: </a:t>
-            </a:r>
-            <a:r>
-              <a:rPr lang="en-US" sz="1000" dirty="0">
-                <a:latin typeface="Helvetica Neue"/>
-                <a:cs typeface="Helvetica Neue"/>
-              </a:rPr>
-              <a:t>What will people/users be doing differently if your solutions work? </a:t>
-            </a:r>
-            <a:r>
-              <a:rPr lang="en-US" sz="1000" i="1" dirty="0">
-                <a:latin typeface="Helvetica Neue"/>
-                <a:cs typeface="Helvetica Neue"/>
-              </a:rPr>
-              <a:t>Consider metrics that indicate customer success like average order value, time on site, and retention rate.) </a:t>
+              <a:t> </a:t>
             </a:r>
             <a:endParaRPr lang="en-US" sz="1000" i="1" dirty="0">
               <a:latin typeface="Helvetica Neue"/>
@@ -4925,7 +5223,7 @@
                 <a:latin typeface="Helvetica Neue" charset="0"/>
                 <a:cs typeface="Helvetica Neue" charset="0"/>
               </a:rPr>
-              <a:t>Title of initiative:</a:t>
+              <a:t>Title of initiative: Clair: Monitoreo Inteligente de la Calidad del Aire Interior</a:t>
             </a:r>
             <a:endParaRPr lang="en-US" sz="1000" dirty="0">
               <a:latin typeface="Helvetica Neue" charset="0"/>
@@ -4967,7 +5265,7 @@
                 <a:latin typeface="Helvetica Neue" charset="0"/>
                 <a:cs typeface="Helvetica Neue" charset="0"/>
               </a:rPr>
-              <a:t>Date:</a:t>
+              <a:t>Date: 3 de abril de 2026</a:t>
             </a:r>
             <a:endParaRPr lang="en-US" sz="1000">
               <a:latin typeface="Helvetica Neue" charset="0"/>
@@ -5009,403 +5307,11 @@
                 <a:latin typeface="Helvetica Neue" charset="0"/>
                 <a:cs typeface="Helvetica Neue" charset="0"/>
               </a:rPr>
-              <a:t>Iteration:</a:t>
+              <a:t>Iteration: 1</a:t>
             </a:r>
             <a:endParaRPr lang="en-US" sz="1000">
               <a:latin typeface="Helvetica Neue" charset="0"/>
               <a:cs typeface="Helvetica Neue" charset="0"/>
-            </a:endParaRPr>
-          </a:p>
-        </p:txBody>
-      </p:sp>
-      <p:sp>
-        <p:nvSpPr>
-          <p:cNvPr id="20" name="TextBox 19"/>
-          <p:cNvSpPr txBox="1"/>
-          <p:nvPr/>
-        </p:nvSpPr>
-        <p:spPr>
-          <a:xfrm>
-            <a:off x="7200900" y="2976563"/>
-            <a:ext cx="1143000" cy="2124075"/>
-          </a:xfrm>
-          <a:prstGeom prst="rect">
-            <a:avLst/>
-          </a:prstGeom>
-          <a:noFill/>
-        </p:spPr>
-        <p:txBody>
-          <a:bodyPr>
-            <a:spAutoFit/>
-          </a:bodyPr>
-          <a:lstStyle/>
-          <a:p>
-            <a:pPr>
-              <a:defRPr/>
-            </a:pPr>
-            <a:r>
-              <a:rPr lang="en-US" sz="13200" dirty="0">
-                <a:solidFill>
-                  <a:schemeClr val="bg1">
-                    <a:lumMod val="85000"/>
-                  </a:schemeClr>
-                </a:solidFill>
-                <a:latin typeface="Helvetica Neue"/>
-                <a:cs typeface="Helvetica Neue"/>
-              </a:rPr>
-              <a:t>5</a:t>
-            </a:r>
-            <a:endParaRPr lang="en-US" sz="13200" dirty="0">
-              <a:solidFill>
-                <a:schemeClr val="bg1">
-                  <a:lumMod val="85000"/>
-                </a:schemeClr>
-              </a:solidFill>
-              <a:latin typeface="Helvetica Neue"/>
-              <a:cs typeface="Helvetica Neue"/>
-            </a:endParaRPr>
-          </a:p>
-        </p:txBody>
-      </p:sp>
-      <p:sp>
-        <p:nvSpPr>
-          <p:cNvPr id="22" name="TextBox 21"/>
-          <p:cNvSpPr txBox="1"/>
-          <p:nvPr/>
-        </p:nvSpPr>
-        <p:spPr>
-          <a:xfrm>
-            <a:off x="2811463" y="4429125"/>
-            <a:ext cx="1143000" cy="2124075"/>
-          </a:xfrm>
-          <a:prstGeom prst="rect">
-            <a:avLst/>
-          </a:prstGeom>
-          <a:noFill/>
-        </p:spPr>
-        <p:txBody>
-          <a:bodyPr>
-            <a:spAutoFit/>
-          </a:bodyPr>
-          <a:lstStyle/>
-          <a:p>
-            <a:pPr>
-              <a:defRPr/>
-            </a:pPr>
-            <a:r>
-              <a:rPr lang="en-US" sz="13200" dirty="0">
-                <a:solidFill>
-                  <a:schemeClr val="bg1">
-                    <a:lumMod val="85000"/>
-                  </a:schemeClr>
-                </a:solidFill>
-                <a:latin typeface="Helvetica Neue"/>
-                <a:cs typeface="Helvetica Neue"/>
-              </a:rPr>
-              <a:t>3</a:t>
-            </a:r>
-            <a:endParaRPr lang="en-US" sz="13200" dirty="0">
-              <a:solidFill>
-                <a:schemeClr val="bg1">
-                  <a:lumMod val="85000"/>
-                </a:schemeClr>
-              </a:solidFill>
-              <a:latin typeface="Helvetica Neue"/>
-              <a:cs typeface="Helvetica Neue"/>
-            </a:endParaRPr>
-          </a:p>
-        </p:txBody>
-      </p:sp>
-      <p:sp>
-        <p:nvSpPr>
-          <p:cNvPr id="23" name="TextBox 22"/>
-          <p:cNvSpPr txBox="1"/>
-          <p:nvPr/>
-        </p:nvSpPr>
-        <p:spPr>
-          <a:xfrm>
-            <a:off x="11582400" y="7663512"/>
-            <a:ext cx="1087347" cy="2124075"/>
-          </a:xfrm>
-          <a:prstGeom prst="rect">
-            <a:avLst/>
-          </a:prstGeom>
-          <a:noFill/>
-        </p:spPr>
-        <p:txBody>
-          <a:bodyPr wrap="square">
-            <a:spAutoFit/>
-          </a:bodyPr>
-          <a:lstStyle/>
-          <a:p>
-            <a:pPr>
-              <a:defRPr/>
-            </a:pPr>
-            <a:r>
-              <a:rPr lang="en-US" sz="13200" dirty="0">
-                <a:solidFill>
-                  <a:schemeClr val="bg1">
-                    <a:lumMod val="85000"/>
-                  </a:schemeClr>
-                </a:solidFill>
-                <a:latin typeface="Helvetica Neue"/>
-                <a:cs typeface="Helvetica Neue"/>
-              </a:rPr>
-              <a:t>8</a:t>
-            </a:r>
-            <a:endParaRPr lang="en-US" sz="13200" dirty="0">
-              <a:solidFill>
-                <a:schemeClr val="bg1">
-                  <a:lumMod val="85000"/>
-                </a:schemeClr>
-              </a:solidFill>
-              <a:latin typeface="Helvetica Neue"/>
-              <a:cs typeface="Helvetica Neue"/>
-            </a:endParaRPr>
-          </a:p>
-        </p:txBody>
-      </p:sp>
-      <p:sp>
-        <p:nvSpPr>
-          <p:cNvPr id="24" name="TextBox 23"/>
-          <p:cNvSpPr txBox="1"/>
-          <p:nvPr/>
-        </p:nvSpPr>
-        <p:spPr>
-          <a:xfrm>
-            <a:off x="2743200" y="1704994"/>
-            <a:ext cx="1143000" cy="2124075"/>
-          </a:xfrm>
-          <a:prstGeom prst="rect">
-            <a:avLst/>
-          </a:prstGeom>
-          <a:noFill/>
-        </p:spPr>
-        <p:txBody>
-          <a:bodyPr>
-            <a:spAutoFit/>
-          </a:bodyPr>
-          <a:lstStyle/>
-          <a:p>
-            <a:pPr>
-              <a:defRPr/>
-            </a:pPr>
-            <a:r>
-              <a:rPr lang="en-US" sz="13200" dirty="0">
-                <a:solidFill>
-                  <a:schemeClr val="bg1">
-                    <a:lumMod val="85000"/>
-                  </a:schemeClr>
-                </a:solidFill>
-                <a:latin typeface="Helvetica Neue"/>
-                <a:cs typeface="Helvetica Neue"/>
-              </a:rPr>
-              <a:t>1</a:t>
-            </a:r>
-            <a:endParaRPr lang="en-US" sz="13200" dirty="0">
-              <a:solidFill>
-                <a:schemeClr val="bg1">
-                  <a:lumMod val="85000"/>
-                </a:schemeClr>
-              </a:solidFill>
-              <a:latin typeface="Helvetica Neue"/>
-              <a:cs typeface="Helvetica Neue"/>
-            </a:endParaRPr>
-          </a:p>
-        </p:txBody>
-      </p:sp>
-      <p:sp>
-        <p:nvSpPr>
-          <p:cNvPr id="25" name="TextBox 24"/>
-          <p:cNvSpPr txBox="1"/>
-          <p:nvPr/>
-        </p:nvSpPr>
-        <p:spPr>
-          <a:xfrm>
-            <a:off x="2811463" y="7663512"/>
-            <a:ext cx="1143000" cy="2124075"/>
-          </a:xfrm>
-          <a:prstGeom prst="rect">
-            <a:avLst/>
-          </a:prstGeom>
-          <a:noFill/>
-        </p:spPr>
-        <p:txBody>
-          <a:bodyPr>
-            <a:spAutoFit/>
-          </a:bodyPr>
-          <a:lstStyle/>
-          <a:p>
-            <a:pPr>
-              <a:defRPr/>
-            </a:pPr>
-            <a:r>
-              <a:rPr lang="en-US" sz="13200" dirty="0">
-                <a:solidFill>
-                  <a:schemeClr val="bg1">
-                    <a:lumMod val="85000"/>
-                  </a:schemeClr>
-                </a:solidFill>
-                <a:latin typeface="Helvetica Neue"/>
-                <a:cs typeface="Helvetica Neue"/>
-              </a:rPr>
-              <a:t>6</a:t>
-            </a:r>
-            <a:endParaRPr lang="en-US" sz="13200" dirty="0">
-              <a:solidFill>
-                <a:schemeClr val="bg1">
-                  <a:lumMod val="85000"/>
-                </a:schemeClr>
-              </a:solidFill>
-              <a:latin typeface="Helvetica Neue"/>
-              <a:cs typeface="Helvetica Neue"/>
-            </a:endParaRPr>
-          </a:p>
-        </p:txBody>
-      </p:sp>
-      <p:sp>
-        <p:nvSpPr>
-          <p:cNvPr id="26" name="TextBox 25"/>
-          <p:cNvSpPr txBox="1"/>
-          <p:nvPr/>
-        </p:nvSpPr>
-        <p:spPr>
-          <a:xfrm>
-            <a:off x="11590335" y="4476218"/>
-            <a:ext cx="1143000" cy="2124075"/>
-          </a:xfrm>
-          <a:prstGeom prst="rect">
-            <a:avLst/>
-          </a:prstGeom>
-          <a:noFill/>
-        </p:spPr>
-        <p:txBody>
-          <a:bodyPr>
-            <a:spAutoFit/>
-          </a:bodyPr>
-          <a:lstStyle/>
-          <a:p>
-            <a:pPr>
-              <a:defRPr/>
-            </a:pPr>
-            <a:r>
-              <a:rPr lang="en-US" sz="13200" dirty="0">
-                <a:solidFill>
-                  <a:schemeClr val="bg1">
-                    <a:lumMod val="85000"/>
-                  </a:schemeClr>
-                </a:solidFill>
-                <a:latin typeface="Helvetica Neue"/>
-                <a:cs typeface="Helvetica Neue"/>
-              </a:rPr>
-              <a:t>4</a:t>
-            </a:r>
-            <a:endParaRPr lang="en-US" sz="13200" dirty="0">
-              <a:solidFill>
-                <a:schemeClr val="bg1">
-                  <a:lumMod val="85000"/>
-                </a:schemeClr>
-              </a:solidFill>
-              <a:latin typeface="Helvetica Neue"/>
-              <a:cs typeface="Helvetica Neue"/>
-            </a:endParaRPr>
-          </a:p>
-        </p:txBody>
-      </p:sp>
-      <p:sp>
-        <p:nvSpPr>
-          <p:cNvPr id="27" name="TextBox 26"/>
-          <p:cNvSpPr txBox="1"/>
-          <p:nvPr/>
-        </p:nvSpPr>
-        <p:spPr>
-          <a:xfrm>
-            <a:off x="7162800" y="7663512"/>
-            <a:ext cx="1143000" cy="2124075"/>
-          </a:xfrm>
-          <a:prstGeom prst="rect">
-            <a:avLst/>
-          </a:prstGeom>
-          <a:noFill/>
-        </p:spPr>
-        <p:txBody>
-          <a:bodyPr>
-            <a:spAutoFit/>
-          </a:bodyPr>
-          <a:lstStyle/>
-          <a:p>
-            <a:pPr>
-              <a:defRPr/>
-            </a:pPr>
-            <a:r>
-              <a:rPr lang="en-US" sz="13200" dirty="0">
-                <a:solidFill>
-                  <a:schemeClr val="bg1">
-                    <a:lumMod val="85000"/>
-                  </a:schemeClr>
-                </a:solidFill>
-                <a:latin typeface="Helvetica Neue"/>
-                <a:cs typeface="Helvetica Neue"/>
-              </a:rPr>
-              <a:t>7</a:t>
-            </a:r>
-            <a:endParaRPr lang="en-US" sz="13200" dirty="0">
-              <a:solidFill>
-                <a:schemeClr val="bg1">
-                  <a:lumMod val="85000"/>
-                </a:schemeClr>
-              </a:solidFill>
-              <a:latin typeface="Helvetica Neue"/>
-              <a:cs typeface="Helvetica Neue"/>
-            </a:endParaRPr>
-          </a:p>
-        </p:txBody>
-      </p:sp>
-      <p:sp>
-        <p:nvSpPr>
-          <p:cNvPr id="28" name="TextBox 27"/>
-          <p:cNvSpPr txBox="1"/>
-          <p:nvPr/>
-        </p:nvSpPr>
-        <p:spPr>
-          <a:xfrm>
-            <a:off x="11658599" y="1699031"/>
-            <a:ext cx="1143000" cy="2124075"/>
-          </a:xfrm>
-          <a:prstGeom prst="rect">
-            <a:avLst/>
-          </a:prstGeom>
-          <a:noFill/>
-        </p:spPr>
-        <p:txBody>
-          <a:bodyPr>
-            <a:spAutoFit/>
-          </a:bodyPr>
-          <a:lstStyle/>
-          <a:p>
-            <a:pPr>
-              <a:defRPr/>
-            </a:pPr>
-            <a:r>
-              <a:rPr lang="en-US" sz="13200" dirty="0">
-                <a:solidFill>
-                  <a:schemeClr val="bg1">
-                    <a:lumMod val="85000"/>
-                  </a:schemeClr>
-                </a:solidFill>
-                <a:latin typeface="Helvetica Neue"/>
-                <a:cs typeface="Helvetica Neue"/>
-              </a:rPr>
-              <a:t>2</a:t>
-            </a:r>
-            <a:endParaRPr lang="en-US" sz="13200" dirty="0">
-              <a:solidFill>
-                <a:schemeClr val="bg1">
-                  <a:lumMod val="85000"/>
-                </a:schemeClr>
-              </a:solidFill>
-              <a:latin typeface="Helvetica Neue"/>
-              <a:cs typeface="Helvetica Neue"/>
             </a:endParaRPr>
           </a:p>
         </p:txBody>
@@ -5510,8 +5416,8 @@
         </p:nvSpPr>
         <p:spPr bwMode="auto">
           <a:xfrm>
-            <a:off x="5867399" y="7010400"/>
-            <a:ext cx="3809999" cy="2730500"/>
+            <a:off x="5867400" y="4352925"/>
+            <a:ext cx="3810000" cy="5387975"/>
           </a:xfrm>
           <a:prstGeom prst="rect">
             <a:avLst/>
@@ -5551,7 +5457,8 @@
             </a:endParaRPr>
           </a:p>
           <a:p>
-            <a:pPr>
+            <a:pPr marL="0" indent="0">
+              <a:buNone/>
               <a:defRPr/>
             </a:pPr>
             <a:r>
@@ -5559,7 +5466,7 @@
                 <a:latin typeface="Helvetica Neue"/>
                 <a:cs typeface="Helvetica Neue"/>
               </a:rPr>
-              <a:t>For each hypothesis from Box 6, identify its riskiest assumptions. Then determine the riskiest one right now. This is the assumption that will cause the entire idea to fail if it’s wrong. </a:t>
+              <a:t>Lo más importante que necesitamos aprender primero es si los administradores de espacios comerciales realmente consideran que la calidad del aire interior es un problema importante para su negocio y si estarían dispuestos a usar una solución para monitorearla y actuar en base a esa información.</a:t>
             </a:r>
             <a:endParaRPr lang="en-US" sz="1000" dirty="0">
               <a:latin typeface="Helvetica Neue"/>
@@ -5576,17 +5483,134 @@
             </a:endParaRPr>
           </a:p>
           <a:p>
-            <a:pPr>
-              <a:defRPr/>
-            </a:pPr>
-            <a:r>
-              <a:rPr lang="en-US" sz="1000" i="1" dirty="0">
+            <a:pPr marL="228600" indent="-228600">
+              <a:buAutoNum type="arabicPeriod"/>
+              <a:defRPr/>
+            </a:pPr>
+            <a:r>
+              <a:rPr lang="en-US" sz="1000" dirty="0">
                 <a:latin typeface="Helvetica Neue"/>
                 <a:cs typeface="Helvetica Neue"/>
               </a:rPr>
-              <a:t>(Hint: In the early stages of a hypothesis focus on risks to value rather than feasibility.) </a:t>
-            </a:r>
-            <a:endParaRPr lang="en-US" sz="1000" i="1" dirty="0">
+              <a:t>Hipótesis 1: El supuesto más riesgoso es que los administradores valorarán los datos en tiempo real de PM2.5 y CO2 y los usarán para tomar decisiones.</a:t>
+            </a:r>
+            <a:endParaRPr lang="en-US" sz="1000" dirty="0">
+              <a:latin typeface="Helvetica Neue"/>
+              <a:cs typeface="Helvetica Neue"/>
+            </a:endParaRPr>
+          </a:p>
+          <a:p>
+            <a:pPr marL="228600" indent="-228600">
+              <a:buAutoNum type="arabicPeriod"/>
+              <a:defRPr/>
+            </a:pPr>
+            <a:r>
+              <a:rPr lang="en-US" sz="1000" dirty="0">
+                <a:latin typeface="Helvetica Neue"/>
+                <a:cs typeface="Helvetica Neue"/>
+              </a:rPr>
+              <a:t>Hipótesis 2: El supuesto más riesgoso es que una interfaz visual simple permitirá a los usuarios comprender fácilmente el estado de la calidad del aire.</a:t>
+            </a:r>
+            <a:endParaRPr lang="en-US" sz="1000" dirty="0">
+              <a:latin typeface="Helvetica Neue"/>
+              <a:cs typeface="Helvetica Neue"/>
+            </a:endParaRPr>
+          </a:p>
+          <a:p>
+            <a:pPr marL="228600" indent="-228600">
+              <a:buAutoNum type="arabicPeriod"/>
+              <a:defRPr/>
+            </a:pPr>
+            <a:r>
+              <a:rPr lang="en-US" sz="1000" dirty="0">
+                <a:latin typeface="Helvetica Neue"/>
+                <a:cs typeface="Helvetica Neue"/>
+              </a:rPr>
+              <a:t>Hipótesis </a:t>
+            </a:r>
+            <a:r>
+              <a:rPr lang="en-US" sz="1000" dirty="0">
+                <a:latin typeface="Helvetica Neue"/>
+                <a:cs typeface="Helvetica Neue"/>
+                <a:sym typeface="+mn-ea"/>
+              </a:rPr>
+              <a:t>3: El supuesto más riesgoso es que los usuarios reaccionarán ante las alertas en tiempo real y realizarán acciones correctivas.</a:t>
+            </a:r>
+            <a:endParaRPr lang="en-US" sz="1000" dirty="0">
+              <a:latin typeface="Helvetica Neue"/>
+              <a:cs typeface="Helvetica Neue"/>
+            </a:endParaRPr>
+          </a:p>
+          <a:p>
+            <a:pPr marL="228600" indent="-228600">
+              <a:buAutoNum type="arabicPeriod"/>
+              <a:defRPr/>
+            </a:pPr>
+            <a:r>
+              <a:rPr lang="en-US" sz="1000" dirty="0">
+                <a:latin typeface="Helvetica Neue"/>
+                <a:cs typeface="Helvetica Neue"/>
+                <a:sym typeface="+mn-ea"/>
+              </a:rPr>
+              <a:t>Hipótesis 4: El supuesto más riesgoso es que los administradores percibirán valor en los reportes históricos como evidencia para mejorar su operación o reputación.</a:t>
+            </a:r>
+            <a:endParaRPr lang="en-US" sz="1000" dirty="0">
+              <a:latin typeface="Helvetica Neue"/>
+              <a:cs typeface="Helvetica Neue"/>
+            </a:endParaRPr>
+          </a:p>
+          <a:p>
+            <a:pPr marL="228600" indent="-228600">
+              <a:buAutoNum type="arabicPeriod"/>
+              <a:defRPr/>
+            </a:pPr>
+            <a:r>
+              <a:rPr lang="en-US" sz="1000" dirty="0">
+                <a:latin typeface="Helvetica Neue"/>
+                <a:cs typeface="Helvetica Neue"/>
+                <a:sym typeface="+mn-ea"/>
+              </a:rPr>
+              <a:t>Hipótesis 5: El supuesto más riesgoso es que los usuarios confiarán en las recomendaciones automáticas y las aplicarán para mejorar su entorno.</a:t>
+            </a:r>
+            <a:endParaRPr lang="en-US" sz="1000" dirty="0">
+              <a:latin typeface="Helvetica Neue"/>
+              <a:cs typeface="Helvetica Neue"/>
+            </a:endParaRPr>
+          </a:p>
+          <a:p>
+            <a:pPr marL="228600" indent="-228600">
+              <a:buAutoNum type="arabicPeriod"/>
+              <a:defRPr/>
+            </a:pPr>
+            <a:endParaRPr lang="en-US" sz="1000" dirty="0">
+              <a:latin typeface="Helvetica Neue"/>
+              <a:cs typeface="Helvetica Neue"/>
+            </a:endParaRPr>
+          </a:p>
+          <a:p>
+            <a:pPr marL="0" indent="0">
+              <a:buNone/>
+              <a:defRPr/>
+            </a:pPr>
+            <a:r>
+              <a:rPr lang="en-US" sz="1000" dirty="0">
+                <a:latin typeface="Helvetica Neue"/>
+                <a:cs typeface="Helvetica Neue"/>
+                <a:sym typeface="+mn-ea"/>
+              </a:rPr>
+              <a:t>El supuesto más riesgoso en este momento es que los administradores de espacios comerciales realmente perciben la calidad del aire interior como un problema relevante y valioso de resolver. Si este supuesto es incorrecto, la idea completa fracasa porque la solución no tendría suficiente valor para ser adoptada.</a:t>
+            </a:r>
+            <a:endParaRPr lang="en-US" sz="1000" dirty="0">
+              <a:latin typeface="Helvetica Neue"/>
+              <a:cs typeface="Helvetica Neue"/>
+            </a:endParaRPr>
+          </a:p>
+          <a:p>
+            <a:pPr marL="228600" indent="-228600">
+              <a:buAutoNum type="arabicPeriod"/>
+              <a:defRPr/>
+            </a:pPr>
+            <a:endParaRPr lang="en-US" sz="1000" dirty="0">
               <a:latin typeface="Helvetica Neue"/>
               <a:cs typeface="Helvetica Neue"/>
             </a:endParaRPr>

</xml_diff>